<commit_message>
Applied same nuance corrections to other study tools.
</commit_message>
<xml_diff>
--- a/Unit-1-Ch-2/Ch2-Dar-al-Islam.pptx
+++ b/Unit-1-Ch-2/Ch2-Dar-al-Islam.pptx
@@ -6495,7 +6495,7 @@
                 <a:ea typeface="Calibri" pitchFamily="34" charset="-122"/>
                 <a:cs typeface="Calibri" pitchFamily="34" charset="-120"/>
               </a:rPr>
-              <a:t>Muslim merchants dominated Indian Ocean, Silk Road, and trans-Saharan routes</a:t>
+              <a:t>Muslim merchants were prominent across Indian Ocean, Silk Road, and trans-Saharan routes — dominant in some segments, but not sole operators in any</a:t>
             </a:r>
             <a:endParaRPr lang="en-US" sz="1000" dirty="0"/>
           </a:p>
@@ -14165,7 +14165,7 @@
                 <a:ea typeface="Calibri" pitchFamily="34" charset="-122"/>
                 <a:cs typeface="Calibri" pitchFamily="34" charset="-120"/>
               </a:rPr>
-              <a:t>Muslim merchants dominated all major Eurasian trade routes. The hawala credit system enabled trust-based long-distance commerce. West African gold (via trans-Saharan trade) financed Mediterranean economies. The Pax Mongolica temporarily boosted Silk Road commerce, benefiting Muslim merchants who could operate across khanate borders.</a:t>
+              <a:t>Muslim merchants were prominent across major Eurasian trade routes, though they were not the only operators — Sogdian, Armenian, Hindu, and Chinese merchants also participated. The hawala credit system enabled trust-based long-distance commerce. West African gold (via trans-Saharan trade) financed Mediterranean economies. The Pax Mongolica temporarily boosted Silk Road commerce.</a:t>
             </a:r>
             <a:endParaRPr lang="en-US" sz="950" dirty="0"/>
           </a:p>

</xml_diff>